<commit_message>
Remove all em-dashes from Session 3 deck copy and notes
Rephrased every on-slide line, kicker, speaker note, and the file title
to use commas, colons, semicolons, or periods instead of em-dashes.

Co-Authored-By: Claude Fable 5 <noreply@anthropic.com>
Claude-Session: https://claude.ai/code/session_01T3HpHgMyeNZj7M9HTKRxMZ
</commit_message>
<xml_diff>
--- a/slides/Session3_Anchored_Belonging_That_Survives_Change.pptx
+++ b/slides/Session3_Anchored_Belonging_That_Survives_Change.pptx
@@ -522,7 +522,7 @@
           <a:p>
             <a:r>
               <a:rPr lang="en-US" dirty="0"/>
-              <a:t>On screen as people arrive. NOTE: 'Anchored — Belonging That Survives Change' is the working title from the brief — Gaelin to confirm final session title before delivery.</a:t>
+              <a:t>On screen as people arrive. NOTE: 'Anchored. Belonging That Survives Change' is the working title from the brief. Gaelin to confirm final session title before delivery.</a:t>
             </a:r>
             <a:endParaRPr lang="en-US" dirty="0"/>
           </a:p>
@@ -610,7 +610,7 @@
           <a:p>
             <a:r>
               <a:rPr lang="en-US" dirty="0"/>
-              <a:t>Evidence slide #2. Deliberately typographic — no imagery of the event itself. Treat with restraint.</a:t>
+              <a:t>Evidence slide #2. Deliberately typographic. No imagery of the event itself. Treat with restraint.</a:t>
             </a:r>
             <a:endParaRPr lang="en-US" dirty="0"/>
           </a:p>
@@ -786,7 +786,7 @@
           <a:p>
             <a:r>
               <a:rPr lang="en-US" dirty="0"/>
-              <a:t>Bridge into the second half. Sets up the evidence wall WITHOUT revealing it — no preview of what comes next.</a:t>
+              <a:t>Bridge into the second half. Sets up the evidence wall WITHOUT revealing it. No preview of what comes next.</a:t>
             </a:r>
             <a:endParaRPr lang="en-US" dirty="0"/>
           </a:p>
@@ -874,7 +874,7 @@
           <a:p>
             <a:r>
               <a:rPr lang="en-US" dirty="0"/>
-              <a:t>BLIND activity — this slide must look complete and standalone. No column structure, no '1 of 3,' no hint of the re-examination that comes two slides later. Preserve strictly.</a:t>
+              <a:t>BLIND activity. This slide must look complete and standalone. No column structure, no '1 of 3,' no hint of the re-examination that comes two slides later. Preserve strictly.</a:t>
             </a:r>
             <a:endParaRPr lang="en-US" dirty="0"/>
           </a:p>
@@ -1050,7 +1050,7 @@
           <a:p>
             <a:r>
               <a:rPr lang="en-US" dirty="0"/>
-              <a:t>Tables re-sort every sticky. Columns two and three get drawn on their paper NOW, live — they were never on screen before this moment.</a:t>
+              <a:t>Tables re-sort every sticky. Columns two and three get drawn on their paper NOW, live. They were never on screen before this moment.</a:t>
             </a:r>
             <a:endParaRPr lang="en-US" dirty="0"/>
           </a:p>
@@ -1226,7 +1226,7 @@
           <a:p>
             <a:r>
               <a:rPr lang="en-US" dirty="0"/>
-              <a:t>Round 1 of the commitment block (~40 min total, three rounds at tables). Advance the deck as each round begins — the round in play is the navy card.</a:t>
+              <a:t>Round 1 of the commitment block (~40 min total, three rounds at tables). Advance the deck as each round begins; the round in play is the navy card.</a:t>
             </a:r>
             <a:endParaRPr lang="en-US" dirty="0"/>
           </a:p>
@@ -1402,7 +1402,7 @@
           <a:p>
             <a:r>
               <a:rPr lang="en-US" dirty="0"/>
-              <a:t>Round 3. Each table writes its one-page compact and keeps it. Collect nothing — the compact belongs to the table.</a:t>
+              <a:t>Round 3. Each table writes its one-page compact and keeps it. Collect nothing; the compact belongs to the table.</a:t>
             </a:r>
             <a:endParaRPr lang="en-US" dirty="0"/>
           </a:p>
@@ -1490,7 +1490,7 @@
           <a:p>
             <a:r>
               <a:rPr lang="en-US" dirty="0"/>
-              <a:t>Stated in minute one. Carry It Up is the physical flip chart in the room — the small gold arrow mark reappears on the Resolved activity and the closing slide.</a:t>
+              <a:t>Stated in minute one. Carry It Up is the physical flip chart in the room. The small gold arrow mark reappears on the Resolved activity and the closing slide.</a:t>
             </a:r>
             <a:endParaRPr lang="en-US" dirty="0"/>
           </a:p>
@@ -1578,7 +1578,7 @@
           <a:p>
             <a:r>
               <a:rPr lang="en-US" dirty="0"/>
-              <a:t>Individual commitment: each person writes one line — one behavior, starting this week. Written before the send-off.</a:t>
+              <a:t>Individual commitment: each person writes one line: one behavior, starting this week. Written before the send-off.</a:t>
             </a:r>
             <a:endParaRPr lang="en-US" dirty="0"/>
           </a:p>
@@ -2018,7 +2018,7 @@
           <a:p>
             <a:r>
               <a:rPr lang="en-US" dirty="0"/>
-              <a:t>The pivot line after the sort debrief — the hinge of the first hour. Hold it in silence for a beat.</a:t>
+              <a:t>The pivot line after the sort debrief, the hinge of the first hour. Hold it in silence for a beat.</a:t>
             </a:r>
             <a:endParaRPr lang="en-US" dirty="0"/>
           </a:p>
@@ -2282,7 +2282,7 @@
           <a:p>
             <a:r>
               <a:rPr lang="en-US" dirty="0"/>
-              <a:t>Evidence slide #1. Gaelin narrates the detail — the slide holds the skeleton. One headline finding per anchor.</a:t>
+              <a:t>Evidence slide #1. Gaelin narrates the detail; the slide holds the skeleton. One headline finding per anchor.</a:t>
             </a:r>
             <a:endParaRPr lang="en-US" dirty="0"/>
           </a:p>
@@ -3123,7 +3123,7 @@
                 <a:ea typeface="Arial" pitchFamily="34" charset="-122"/>
                 <a:cs typeface="Arial" pitchFamily="34" charset="-120"/>
               </a:rPr>
-              <a:t>approval — the highest</a:t>
+              <a:t>approval, the highest</a:t>
             </a:r>
             <a:endParaRPr lang="en-US" sz="1500" dirty="0"/>
           </a:p>
@@ -3224,7 +3224,7 @@
                 <a:ea typeface="Arial" pitchFamily="34" charset="-122"/>
                 <a:cs typeface="Arial" pitchFamily="34" charset="-120"/>
               </a:rPr>
-              <a:t>Within two years, the country returned to — and then exceeded — its prior divisions.</a:t>
+              <a:t>Within two years, the country returned to, and then exceeded, its prior divisions.</a:t>
             </a:r>
             <a:endParaRPr lang="en-US" sz="1900" dirty="0"/>
           </a:p>
@@ -4016,7 +4016,7 @@
                 <a:ea typeface="Arial" pitchFamily="34" charset="-122"/>
                 <a:cs typeface="Arial" pitchFamily="34" charset="-120"/>
               </a:rPr>
-              <a:t>Observable things only — things you could point to, not feelings. One per sticky.</a:t>
+              <a:t>Observable things only: things you could point to, not feelings. One per sticky.</a:t>
             </a:r>
             <a:endParaRPr lang="en-US" sz="2000" dirty="0"/>
           </a:p>
@@ -4155,7 +4155,7 @@
                 <a:ea typeface="Arial" pitchFamily="34" charset="-122"/>
                 <a:cs typeface="Arial" pitchFamily="34" charset="-120"/>
               </a:rPr>
-              <a:t>BEFORE WE DECIDE WHAT THIS EVIDENCE MEANS —</a:t>
+              <a:t>BEFORE WE DECIDE WHAT THIS EVIDENCE MEANS</a:t>
             </a:r>
             <a:endParaRPr lang="en-US" sz="1300" dirty="0"/>
           </a:p>
@@ -4667,7 +4667,7 @@
                 <a:ea typeface="Arial Black" pitchFamily="34" charset="-122"/>
                 <a:cs typeface="Arial Black" pitchFamily="34" charset="-120"/>
               </a:rPr>
-              <a:t> —</a:t>
+              <a:t>:</a:t>
             </a:r>
             <a:endParaRPr lang="en-US" sz="2500" dirty="0"/>
           </a:p>
@@ -4763,7 +4763,7 @@
                 <a:ea typeface="Arial Black" pitchFamily="34" charset="-122"/>
                 <a:cs typeface="Arial Black" pitchFamily="34" charset="-120"/>
               </a:rPr>
-              <a:t> —</a:t>
+              <a:t>:</a:t>
             </a:r>
             <a:endParaRPr lang="en-US" sz="2500" dirty="0"/>
           </a:p>
@@ -5125,7 +5125,7 @@
                 <a:ea typeface="Arial" pitchFamily="34" charset="-122"/>
                 <a:cs typeface="Arial" pitchFamily="34" charset="-120"/>
               </a:rPr>
-              <a:t>Not aspirations — observable pictures.</a:t>
+              <a:t>Not aspirations. Observable pictures.</a:t>
             </a:r>
             <a:endParaRPr lang="en-US" sz="2000" dirty="0"/>
           </a:p>
@@ -5315,7 +5315,7 @@
                 <a:ea typeface="Arial" pitchFamily="34" charset="-122"/>
                 <a:cs typeface="Arial" pitchFamily="34" charset="-120"/>
               </a:rPr>
-              <a:t>Genuinely broken trust doesn’t belong in this column — it goes to the Carry It Up board.</a:t>
+              <a:t>Genuinely broken trust doesn’t belong in this column. It goes to the Carry It Up board.</a:t>
             </a:r>
             <a:endParaRPr lang="en-US" sz="1500" dirty="0"/>
           </a:p>
@@ -5897,7 +5897,7 @@
                 <a:ea typeface="Arial" pitchFamily="34" charset="-122"/>
                 <a:cs typeface="Arial" pitchFamily="34" charset="-120"/>
               </a:rPr>
-              <a:t>If it’s really a leadership ask — walk it to the Carry It Up board.</a:t>
+              <a:t>If it’s really a leadership ask, walk it to the Carry It Up board.</a:t>
             </a:r>
             <a:endParaRPr lang="en-US" sz="1400" dirty="0"/>
           </a:p>
@@ -6599,7 +6599,7 @@
                 <a:ea typeface="Arial" pitchFamily="34" charset="-122"/>
                 <a:cs typeface="Arial" pitchFamily="34" charset="-120"/>
               </a:rPr>
-              <a:t>If it’s really a leadership ask — walk it to the Carry It Up board.</a:t>
+              <a:t>If it’s really a leadership ask, walk it to the Carry It Up board.</a:t>
             </a:r>
             <a:endParaRPr lang="en-US" sz="1400" dirty="0"/>
           </a:p>
@@ -7301,7 +7301,7 @@
                 <a:ea typeface="Arial" pitchFamily="34" charset="-122"/>
                 <a:cs typeface="Arial" pitchFamily="34" charset="-120"/>
               </a:rPr>
-              <a:t>If it’s really a leadership ask — walk it to the Carry It Up board.</a:t>
+              <a:t>If it’s really a leadership ask, walk it to the Carry It Up board.</a:t>
             </a:r>
             <a:endParaRPr lang="en-US" sz="1400" dirty="0"/>
           </a:p>
@@ -7720,7 +7720,7 @@
                 <a:ea typeface="Arial" pitchFamily="34" charset="-122"/>
                 <a:cs typeface="Arial" pitchFamily="34" charset="-120"/>
               </a:rPr>
-              <a:t>We talk about us — not about people who aren’t in the room.</a:t>
+              <a:t>We talk about us, not about people who aren’t in the room.</a:t>
             </a:r>
             <a:endParaRPr lang="en-US" sz="2000" dirty="0"/>
           </a:p>
@@ -9992,7 +9992,7 @@
                 <a:ea typeface="Arial" pitchFamily="34" charset="-122"/>
                 <a:cs typeface="Arial" pitchFamily="34" charset="-120"/>
               </a:rPr>
-              <a:t>A card can sit under more than one — pick where it pulls strongest.</a:t>
+              <a:t>A card can sit under more than one. Pick where it pulls strongest.</a:t>
             </a:r>
             <a:endParaRPr lang="en-US" sz="1800" dirty="0"/>
           </a:p>
@@ -10246,7 +10246,7 @@
                 <a:ea typeface="Arial" pitchFamily="34" charset="-122"/>
                 <a:cs typeface="Arial" pitchFamily="34" charset="-120"/>
               </a:rPr>
-              <a:t> — your </a:t>
+              <a:t>: your </a:t>
             </a:r>
             <a:pPr indent="0" marL="0">
               <a:lnSpc>
@@ -11507,7 +11507,7 @@
                 <a:ea typeface="Arial Black" pitchFamily="34" charset="-122"/>
                 <a:cs typeface="Arial Black" pitchFamily="34" charset="-120"/>
               </a:rPr>
-              <a:t>Threat bonds groups fast — and leaves them fragile.</a:t>
+              <a:t>Threat bonds groups fast and leaves them fragile.</a:t>
             </a:r>
             <a:endParaRPr lang="en-US" sz="1650" dirty="0"/>
           </a:p>
@@ -12005,7 +12005,7 @@
                 <a:ea typeface="Arial" pitchFamily="34" charset="-122"/>
                 <a:cs typeface="Arial" pitchFamily="34" charset="-120"/>
               </a:rPr>
-              <a:t>Silence, matching, looking unified — while trust goes underground.</a:t>
+              <a:t>Silence, matching, looking unified, while trust goes underground.</a:t>
             </a:r>
             <a:endParaRPr lang="en-US" sz="1350" dirty="0"/>
           </a:p>

</xml_diff>